<commit_message>
Feat #56 added Item Box
</commit_message>
<xml_diff>
--- a/RawImages/imagePPT.pptx
+++ b/RawImages/imagePPT.pptx
@@ -4547,7 +4547,7 @@
         </p:blipFill>
         <p:spPr>
           <a:xfrm>
-            <a:off x="0" y="0"/>
+            <a:off x="115147" y="-12209"/>
             <a:ext cx="12192000" cy="6858000"/>
           </a:xfrm>
           <a:prstGeom prst="rect">
@@ -4555,6 +4555,109 @@
           </a:prstGeom>
         </p:spPr>
       </p:pic>
+      <p:grpSp>
+        <p:nvGrpSpPr>
+          <p:cNvPr id="6" name="그룹 5">
+            <a:extLst>
+              <a:ext uri="{FF2B5EF4-FFF2-40B4-BE49-F238E27FC236}">
+                <a16:creationId xmlns:a16="http://schemas.microsoft.com/office/drawing/2014/main" id="{8919BEF4-8226-F864-62F0-7F24EC05D5A7}"/>
+              </a:ext>
+            </a:extLst>
+          </p:cNvPr>
+          <p:cNvGrpSpPr/>
+          <p:nvPr/>
+        </p:nvGrpSpPr>
+        <p:grpSpPr>
+          <a:xfrm>
+            <a:off x="4629296" y="2156791"/>
+            <a:ext cx="2520000" cy="2520000"/>
+            <a:chOff x="4629296" y="2156791"/>
+            <a:chExt cx="2520000" cy="2520000"/>
+          </a:xfrm>
+        </p:grpSpPr>
+        <p:sp>
+          <p:nvSpPr>
+            <p:cNvPr id="4" name="직사각형 3">
+              <a:extLst>
+                <a:ext uri="{FF2B5EF4-FFF2-40B4-BE49-F238E27FC236}">
+                  <a16:creationId xmlns:a16="http://schemas.microsoft.com/office/drawing/2014/main" id="{681B613E-4E9C-964F-98B0-C4633DAAF046}"/>
+                </a:ext>
+              </a:extLst>
+            </p:cNvPr>
+            <p:cNvSpPr/>
+            <p:nvPr/>
+          </p:nvSpPr>
+          <p:spPr>
+            <a:xfrm>
+              <a:off x="4629296" y="2156791"/>
+              <a:ext cx="2520000" cy="2520000"/>
+            </a:xfrm>
+            <a:prstGeom prst="rect">
+              <a:avLst/>
+            </a:prstGeom>
+            <a:solidFill>
+              <a:srgbClr val="7CCBFF"/>
+            </a:solidFill>
+            <a:ln>
+              <a:noFill/>
+            </a:ln>
+          </p:spPr>
+          <p:style>
+            <a:lnRef idx="2">
+              <a:schemeClr val="accent1">
+                <a:shade val="15000"/>
+              </a:schemeClr>
+            </a:lnRef>
+            <a:fillRef idx="1">
+              <a:schemeClr val="accent1"/>
+            </a:fillRef>
+            <a:effectRef idx="0">
+              <a:schemeClr val="accent1"/>
+            </a:effectRef>
+            <a:fontRef idx="minor">
+              <a:schemeClr val="lt1"/>
+            </a:fontRef>
+          </p:style>
+          <p:txBody>
+            <a:bodyPr rtlCol="0" anchor="ctr"/>
+            <a:lstStyle/>
+            <a:p>
+              <a:pPr algn="ctr"/>
+              <a:endParaRPr lang="ko-KR" altLang="en-US"/>
+            </a:p>
+          </p:txBody>
+        </p:sp>
+        <p:pic>
+          <p:nvPicPr>
+            <p:cNvPr id="3" name="그림 2" descr="깡통, 알루미늄 캔, 음료캔, 병이(가) 표시된 사진&#10;&#10;AI가 생성한 콘텐츠는 부정확할 수 있습니다.">
+              <a:extLst>
+                <a:ext uri="{FF2B5EF4-FFF2-40B4-BE49-F238E27FC236}">
+                  <a16:creationId xmlns:a16="http://schemas.microsoft.com/office/drawing/2014/main" id="{C0DFA825-419E-5C4E-A89B-A0494294D0B7}"/>
+                </a:ext>
+              </a:extLst>
+            </p:cNvPr>
+            <p:cNvPicPr>
+              <a:picLocks noChangeAspect="1"/>
+            </p:cNvPicPr>
+            <p:nvPr/>
+          </p:nvPicPr>
+          <p:blipFill>
+            <a:blip r:embed="rId3"/>
+            <a:stretch>
+              <a:fillRect/>
+            </a:stretch>
+          </p:blipFill>
+          <p:spPr>
+            <a:xfrm>
+              <a:off x="5129553" y="2289386"/>
+              <a:ext cx="1519485" cy="2279227"/>
+            </a:xfrm>
+            <a:prstGeom prst="rect">
+              <a:avLst/>
+            </a:prstGeom>
+          </p:spPr>
+        </p:pic>
+      </p:grpSp>
     </p:spTree>
     <p:extLst>
       <p:ext uri="{BB962C8B-B14F-4D97-AF65-F5344CB8AC3E}">

</xml_diff>

<commit_message>
Feat #59 Particle Effect for map unlock
</commit_message>
<xml_diff>
--- a/RawImages/imagePPT.pptx
+++ b/RawImages/imagePPT.pptx
@@ -8,6 +8,7 @@
     <p:sldId id="256" r:id="rId2"/>
     <p:sldId id="258" r:id="rId3"/>
     <p:sldId id="257" r:id="rId4"/>
+    <p:sldId id="259" r:id="rId5"/>
   </p:sldIdLst>
   <p:sldSz cx="12192000" cy="6858000"/>
   <p:notesSz cx="6858000" cy="9144000"/>
@@ -261,7 +262,7 @@
           <a:p>
             <a:fld id="{F3E3B444-461C-43DF-9895-EF8F91AA3F26}" type="datetimeFigureOut">
               <a:rPr lang="ko-KR" altLang="en-US" smtClean="0"/>
-              <a:t>2025-06-01</a:t>
+              <a:t>2025-06-02</a:t>
             </a:fld>
             <a:endParaRPr lang="ko-KR" altLang="en-US"/>
           </a:p>
@@ -459,7 +460,7 @@
           <a:p>
             <a:fld id="{F3E3B444-461C-43DF-9895-EF8F91AA3F26}" type="datetimeFigureOut">
               <a:rPr lang="ko-KR" altLang="en-US" smtClean="0"/>
-              <a:t>2025-06-01</a:t>
+              <a:t>2025-06-02</a:t>
             </a:fld>
             <a:endParaRPr lang="ko-KR" altLang="en-US"/>
           </a:p>
@@ -667,7 +668,7 @@
           <a:p>
             <a:fld id="{F3E3B444-461C-43DF-9895-EF8F91AA3F26}" type="datetimeFigureOut">
               <a:rPr lang="ko-KR" altLang="en-US" smtClean="0"/>
-              <a:t>2025-06-01</a:t>
+              <a:t>2025-06-02</a:t>
             </a:fld>
             <a:endParaRPr lang="ko-KR" altLang="en-US"/>
           </a:p>
@@ -865,7 +866,7 @@
           <a:p>
             <a:fld id="{F3E3B444-461C-43DF-9895-EF8F91AA3F26}" type="datetimeFigureOut">
               <a:rPr lang="ko-KR" altLang="en-US" smtClean="0"/>
-              <a:t>2025-06-01</a:t>
+              <a:t>2025-06-02</a:t>
             </a:fld>
             <a:endParaRPr lang="ko-KR" altLang="en-US"/>
           </a:p>
@@ -1140,7 +1141,7 @@
           <a:p>
             <a:fld id="{F3E3B444-461C-43DF-9895-EF8F91AA3F26}" type="datetimeFigureOut">
               <a:rPr lang="ko-KR" altLang="en-US" smtClean="0"/>
-              <a:t>2025-06-01</a:t>
+              <a:t>2025-06-02</a:t>
             </a:fld>
             <a:endParaRPr lang="ko-KR" altLang="en-US"/>
           </a:p>
@@ -1405,7 +1406,7 @@
           <a:p>
             <a:fld id="{F3E3B444-461C-43DF-9895-EF8F91AA3F26}" type="datetimeFigureOut">
               <a:rPr lang="ko-KR" altLang="en-US" smtClean="0"/>
-              <a:t>2025-06-01</a:t>
+              <a:t>2025-06-02</a:t>
             </a:fld>
             <a:endParaRPr lang="ko-KR" altLang="en-US"/>
           </a:p>
@@ -1817,7 +1818,7 @@
           <a:p>
             <a:fld id="{F3E3B444-461C-43DF-9895-EF8F91AA3F26}" type="datetimeFigureOut">
               <a:rPr lang="ko-KR" altLang="en-US" smtClean="0"/>
-              <a:t>2025-06-01</a:t>
+              <a:t>2025-06-02</a:t>
             </a:fld>
             <a:endParaRPr lang="ko-KR" altLang="en-US"/>
           </a:p>
@@ -1958,7 +1959,7 @@
           <a:p>
             <a:fld id="{F3E3B444-461C-43DF-9895-EF8F91AA3F26}" type="datetimeFigureOut">
               <a:rPr lang="ko-KR" altLang="en-US" smtClean="0"/>
-              <a:t>2025-06-01</a:t>
+              <a:t>2025-06-02</a:t>
             </a:fld>
             <a:endParaRPr lang="ko-KR" altLang="en-US"/>
           </a:p>
@@ -2071,7 +2072,7 @@
           <a:p>
             <a:fld id="{F3E3B444-461C-43DF-9895-EF8F91AA3F26}" type="datetimeFigureOut">
               <a:rPr lang="ko-KR" altLang="en-US" smtClean="0"/>
-              <a:t>2025-06-01</a:t>
+              <a:t>2025-06-02</a:t>
             </a:fld>
             <a:endParaRPr lang="ko-KR" altLang="en-US"/>
           </a:p>
@@ -2382,7 +2383,7 @@
           <a:p>
             <a:fld id="{F3E3B444-461C-43DF-9895-EF8F91AA3F26}" type="datetimeFigureOut">
               <a:rPr lang="ko-KR" altLang="en-US" smtClean="0"/>
-              <a:t>2025-06-01</a:t>
+              <a:t>2025-06-02</a:t>
             </a:fld>
             <a:endParaRPr lang="ko-KR" altLang="en-US"/>
           </a:p>
@@ -2670,7 +2671,7 @@
           <a:p>
             <a:fld id="{F3E3B444-461C-43DF-9895-EF8F91AA3F26}" type="datetimeFigureOut">
               <a:rPr lang="ko-KR" altLang="en-US" smtClean="0"/>
-              <a:t>2025-06-01</a:t>
+              <a:t>2025-06-02</a:t>
             </a:fld>
             <a:endParaRPr lang="ko-KR" altLang="en-US"/>
           </a:p>
@@ -2917,7 +2918,7 @@
           <a:p>
             <a:fld id="{F3E3B444-461C-43DF-9895-EF8F91AA3F26}" type="datetimeFigureOut">
               <a:rPr lang="ko-KR" altLang="en-US" smtClean="0"/>
-              <a:t>2025-06-01</a:t>
+              <a:t>2025-06-02</a:t>
             </a:fld>
             <a:endParaRPr lang="ko-KR" altLang="en-US"/>
           </a:p>
@@ -4832,6 +4833,88 @@
     <p:extLst>
       <p:ext uri="{BB962C8B-B14F-4D97-AF65-F5344CB8AC3E}">
         <p14:creationId xmlns:p14="http://schemas.microsoft.com/office/powerpoint/2010/main" val="1871351606"/>
+      </p:ext>
+    </p:extLst>
+  </p:cSld>
+  <p:clrMapOvr>
+    <a:masterClrMapping/>
+  </p:clrMapOvr>
+</p:sld>
+</file>
+
+<file path=ppt/slides/slide4.xml><?xml version="1.0" encoding="utf-8"?>
+<p:sld xmlns:a="http://schemas.openxmlformats.org/drawingml/2006/main" xmlns:r="http://schemas.openxmlformats.org/officeDocument/2006/relationships" xmlns:p="http://schemas.openxmlformats.org/presentationml/2006/main">
+  <p:cSld>
+    <p:spTree>
+      <p:nvGrpSpPr>
+        <p:cNvPr id="1" name=""/>
+        <p:cNvGrpSpPr/>
+        <p:nvPr/>
+      </p:nvGrpSpPr>
+      <p:grpSpPr>
+        <a:xfrm>
+          <a:off x="0" y="0"/>
+          <a:ext cx="0" cy="0"/>
+          <a:chOff x="0" y="0"/>
+          <a:chExt cx="0" cy="0"/>
+        </a:xfrm>
+      </p:grpSpPr>
+      <p:sp>
+        <p:nvSpPr>
+          <p:cNvPr id="5" name="순서도: 판단 4">
+            <a:extLst>
+              <a:ext uri="{FF2B5EF4-FFF2-40B4-BE49-F238E27FC236}">
+                <a16:creationId xmlns:a16="http://schemas.microsoft.com/office/drawing/2014/main" id="{A3D28B9D-1DAE-FDF5-B96D-0583A31B4E23}"/>
+              </a:ext>
+            </a:extLst>
+          </p:cNvPr>
+          <p:cNvSpPr/>
+          <p:nvPr/>
+        </p:nvSpPr>
+        <p:spPr>
+          <a:xfrm rot="5400000">
+            <a:off x="6414052" y="2597426"/>
+            <a:ext cx="636104" cy="291547"/>
+          </a:xfrm>
+          <a:prstGeom prst="flowChartDecision">
+            <a:avLst/>
+          </a:prstGeom>
+          <a:solidFill>
+            <a:srgbClr val="FFFF00"/>
+          </a:solidFill>
+          <a:ln>
+            <a:noFill/>
+          </a:ln>
+        </p:spPr>
+        <p:style>
+          <a:lnRef idx="2">
+            <a:schemeClr val="accent1">
+              <a:shade val="15000"/>
+            </a:schemeClr>
+          </a:lnRef>
+          <a:fillRef idx="1">
+            <a:schemeClr val="accent1"/>
+          </a:fillRef>
+          <a:effectRef idx="0">
+            <a:schemeClr val="accent1"/>
+          </a:effectRef>
+          <a:fontRef idx="minor">
+            <a:schemeClr val="lt1"/>
+          </a:fontRef>
+        </p:style>
+        <p:txBody>
+          <a:bodyPr rtlCol="0" anchor="ctr"/>
+          <a:lstStyle/>
+          <a:p>
+            <a:pPr algn="ctr"/>
+            <a:endParaRPr lang="ko-KR" altLang="en-US"/>
+          </a:p>
+        </p:txBody>
+      </p:sp>
+    </p:spTree>
+    <p:extLst>
+      <p:ext uri="{BB962C8B-B14F-4D97-AF65-F5344CB8AC3E}">
+        <p14:creationId xmlns:p14="http://schemas.microsoft.com/office/powerpoint/2010/main" val="763899694"/>
       </p:ext>
     </p:extLst>
   </p:cSld>

</xml_diff>

<commit_message>
Feat #85 Gauge For Items and Penalties
</commit_message>
<xml_diff>
--- a/RawImages/imagePPT.pptx
+++ b/RawImages/imagePPT.pptx
@@ -262,7 +262,7 @@
           <a:p>
             <a:fld id="{F3E3B444-461C-43DF-9895-EF8F91AA3F26}" type="datetimeFigureOut">
               <a:rPr lang="ko-KR" altLang="en-US" smtClean="0"/>
-              <a:t>2025-06-07</a:t>
+              <a:t>2025-06-15</a:t>
             </a:fld>
             <a:endParaRPr lang="ko-KR" altLang="en-US"/>
           </a:p>
@@ -460,7 +460,7 @@
           <a:p>
             <a:fld id="{F3E3B444-461C-43DF-9895-EF8F91AA3F26}" type="datetimeFigureOut">
               <a:rPr lang="ko-KR" altLang="en-US" smtClean="0"/>
-              <a:t>2025-06-07</a:t>
+              <a:t>2025-06-15</a:t>
             </a:fld>
             <a:endParaRPr lang="ko-KR" altLang="en-US"/>
           </a:p>
@@ -668,7 +668,7 @@
           <a:p>
             <a:fld id="{F3E3B444-461C-43DF-9895-EF8F91AA3F26}" type="datetimeFigureOut">
               <a:rPr lang="ko-KR" altLang="en-US" smtClean="0"/>
-              <a:t>2025-06-07</a:t>
+              <a:t>2025-06-15</a:t>
             </a:fld>
             <a:endParaRPr lang="ko-KR" altLang="en-US"/>
           </a:p>
@@ -866,7 +866,7 @@
           <a:p>
             <a:fld id="{F3E3B444-461C-43DF-9895-EF8F91AA3F26}" type="datetimeFigureOut">
               <a:rPr lang="ko-KR" altLang="en-US" smtClean="0"/>
-              <a:t>2025-06-07</a:t>
+              <a:t>2025-06-15</a:t>
             </a:fld>
             <a:endParaRPr lang="ko-KR" altLang="en-US"/>
           </a:p>
@@ -1141,7 +1141,7 @@
           <a:p>
             <a:fld id="{F3E3B444-461C-43DF-9895-EF8F91AA3F26}" type="datetimeFigureOut">
               <a:rPr lang="ko-KR" altLang="en-US" smtClean="0"/>
-              <a:t>2025-06-07</a:t>
+              <a:t>2025-06-15</a:t>
             </a:fld>
             <a:endParaRPr lang="ko-KR" altLang="en-US"/>
           </a:p>
@@ -1406,7 +1406,7 @@
           <a:p>
             <a:fld id="{F3E3B444-461C-43DF-9895-EF8F91AA3F26}" type="datetimeFigureOut">
               <a:rPr lang="ko-KR" altLang="en-US" smtClean="0"/>
-              <a:t>2025-06-07</a:t>
+              <a:t>2025-06-15</a:t>
             </a:fld>
             <a:endParaRPr lang="ko-KR" altLang="en-US"/>
           </a:p>
@@ -1818,7 +1818,7 @@
           <a:p>
             <a:fld id="{F3E3B444-461C-43DF-9895-EF8F91AA3F26}" type="datetimeFigureOut">
               <a:rPr lang="ko-KR" altLang="en-US" smtClean="0"/>
-              <a:t>2025-06-07</a:t>
+              <a:t>2025-06-15</a:t>
             </a:fld>
             <a:endParaRPr lang="ko-KR" altLang="en-US"/>
           </a:p>
@@ -1959,7 +1959,7 @@
           <a:p>
             <a:fld id="{F3E3B444-461C-43DF-9895-EF8F91AA3F26}" type="datetimeFigureOut">
               <a:rPr lang="ko-KR" altLang="en-US" smtClean="0"/>
-              <a:t>2025-06-07</a:t>
+              <a:t>2025-06-15</a:t>
             </a:fld>
             <a:endParaRPr lang="ko-KR" altLang="en-US"/>
           </a:p>
@@ -2072,7 +2072,7 @@
           <a:p>
             <a:fld id="{F3E3B444-461C-43DF-9895-EF8F91AA3F26}" type="datetimeFigureOut">
               <a:rPr lang="ko-KR" altLang="en-US" smtClean="0"/>
-              <a:t>2025-06-07</a:t>
+              <a:t>2025-06-15</a:t>
             </a:fld>
             <a:endParaRPr lang="ko-KR" altLang="en-US"/>
           </a:p>
@@ -2383,7 +2383,7 @@
           <a:p>
             <a:fld id="{F3E3B444-461C-43DF-9895-EF8F91AA3F26}" type="datetimeFigureOut">
               <a:rPr lang="ko-KR" altLang="en-US" smtClean="0"/>
-              <a:t>2025-06-07</a:t>
+              <a:t>2025-06-15</a:t>
             </a:fld>
             <a:endParaRPr lang="ko-KR" altLang="en-US"/>
           </a:p>
@@ -2671,7 +2671,7 @@
           <a:p>
             <a:fld id="{F3E3B444-461C-43DF-9895-EF8F91AA3F26}" type="datetimeFigureOut">
               <a:rPr lang="ko-KR" altLang="en-US" smtClean="0"/>
-              <a:t>2025-06-07</a:t>
+              <a:t>2025-06-15</a:t>
             </a:fld>
             <a:endParaRPr lang="ko-KR" altLang="en-US"/>
           </a:p>
@@ -2918,7 +2918,7 @@
           <a:p>
             <a:fld id="{F3E3B444-461C-43DF-9895-EF8F91AA3F26}" type="datetimeFigureOut">
               <a:rPr lang="ko-KR" altLang="en-US" smtClean="0"/>
-              <a:t>2025-06-07</a:t>
+              <a:t>2025-06-15</a:t>
             </a:fld>
             <a:endParaRPr lang="ko-KR" altLang="en-US"/>
           </a:p>
@@ -5490,6 +5490,58 @@
           </a:prstGeom>
           <a:solidFill>
             <a:srgbClr val="FFFF00"/>
+          </a:solidFill>
+          <a:ln>
+            <a:noFill/>
+          </a:ln>
+        </p:spPr>
+        <p:style>
+          <a:lnRef idx="2">
+            <a:schemeClr val="accent1">
+              <a:shade val="15000"/>
+            </a:schemeClr>
+          </a:lnRef>
+          <a:fillRef idx="1">
+            <a:schemeClr val="accent1"/>
+          </a:fillRef>
+          <a:effectRef idx="0">
+            <a:schemeClr val="accent1"/>
+          </a:effectRef>
+          <a:fontRef idx="minor">
+            <a:schemeClr val="lt1"/>
+          </a:fontRef>
+        </p:style>
+        <p:txBody>
+          <a:bodyPr rtlCol="0" anchor="ctr"/>
+          <a:lstStyle/>
+          <a:p>
+            <a:pPr algn="ctr"/>
+            <a:endParaRPr lang="ko-KR" altLang="en-US"/>
+          </a:p>
+        </p:txBody>
+      </p:sp>
+      <p:sp>
+        <p:nvSpPr>
+          <p:cNvPr id="2" name="직사각형 1">
+            <a:extLst>
+              <a:ext uri="{FF2B5EF4-FFF2-40B4-BE49-F238E27FC236}">
+                <a16:creationId xmlns:a16="http://schemas.microsoft.com/office/drawing/2014/main" id="{433BFDC5-DCE6-1019-E005-D20BE59A0BDC}"/>
+              </a:ext>
+            </a:extLst>
+          </p:cNvPr>
+          <p:cNvSpPr/>
+          <p:nvPr/>
+        </p:nvSpPr>
+        <p:spPr>
+          <a:xfrm>
+            <a:off x="2466109" y="738909"/>
+            <a:ext cx="3269673" cy="64655"/>
+          </a:xfrm>
+          <a:prstGeom prst="rect">
+            <a:avLst/>
+          </a:prstGeom>
+          <a:solidFill>
+            <a:schemeClr val="bg1"/>
           </a:solidFill>
           <a:ln>
             <a:noFill/>

</xml_diff>